<commit_message>
Fix licence redundancy and add scheduled-prompt tip after Cowork tasks
Co-authored-by: Copilot <223556219+Copilot@users.noreply.github.com>
</commit_message>
<xml_diff>
--- a/slides/business-lite.pptx
+++ b/slides/business-lite.pptx
@@ -17,6 +17,7 @@
     <p:sldId id="265" r:id="rId16"/>
     <p:sldId id="266" r:id="rId17"/>
     <p:sldId id="267" r:id="rId18"/>
+    <p:sldId id="268" r:id="rId19"/>
   </p:sldIdLst>
   <p:sldSz cx="9144000" cy="5143500" type="screen4x3"/>
   <p:notesSz cx="6858000" cy="9144000"/>
@@ -5029,6 +5030,299 @@
 </file>
 
 <file path=ppt/slides/slide12.xml><?xml version="1.0" encoding="utf-8"?>
+<p:sld xmlns:a="http://schemas.openxmlformats.org/drawingml/2006/main" xmlns:p="http://schemas.openxmlformats.org/presentationml/2006/main" xmlns:r="http://schemas.openxmlformats.org/officeDocument/2006/relationships">
+  <p:cSld>
+    <p:bg>
+      <p:bgPr>
+        <a:solidFill>
+          <a:srgbClr val="FFFAF5"/>
+        </a:solidFill>
+        <a:effectLst/>
+      </p:bgPr>
+    </p:bg>
+    <p:spTree>
+      <p:nvGrpSpPr>
+        <p:cNvPr id="1" name=""/>
+        <p:cNvGrpSpPr/>
+        <p:nvPr/>
+      </p:nvGrpSpPr>
+      <p:grpSpPr/>
+      <p:sp>
+        <p:nvSpPr>
+          <p:cNvPr id="2" name="TextBox 1"/>
+          <p:cNvSpPr txBox="1"/>
+          <p:nvPr/>
+        </p:nvSpPr>
+        <p:spPr>
+          <a:xfrm>
+            <a:off x="502920" y="228600"/>
+            <a:ext cx="6400800" cy="228600"/>
+          </a:xfrm>
+          <a:prstGeom prst="rect">
+            <a:avLst/>
+          </a:prstGeom>
+          <a:noFill/>
+        </p:spPr>
+        <p:txBody>
+          <a:bodyPr wrap="square" lIns="27432" rIns="27432" tIns="18288" bIns="18288">
+            <a:spAutoFit/>
+          </a:bodyPr>
+          <a:lstStyle/>
+          <a:p>
+            <a:r>
+              <a:rPr sz="900" b="1">
+                <a:solidFill>
+                  <a:srgbClr val="5A6078"/>
+                </a:solidFill>
+                <a:latin typeface="Segoe UI"/>
+              </a:rPr>
+              <a:t>COPILOT COWORK</a:t>
+            </a:r>
+          </a:p>
+        </p:txBody>
+      </p:sp>
+      <p:sp>
+        <p:nvSpPr>
+          <p:cNvPr id="3" name="TextBox 2"/>
+          <p:cNvSpPr txBox="1"/>
+          <p:nvPr/>
+        </p:nvSpPr>
+        <p:spPr>
+          <a:xfrm>
+            <a:off x="502920" y="438912"/>
+            <a:ext cx="7955279" cy="658368"/>
+          </a:xfrm>
+          <a:prstGeom prst="rect">
+            <a:avLst/>
+          </a:prstGeom>
+          <a:noFill/>
+        </p:spPr>
+        <p:txBody>
+          <a:bodyPr wrap="square" lIns="27432" rIns="27432" tIns="18288" bIns="18288">
+            <a:spAutoFit/>
+          </a:bodyPr>
+          <a:lstStyle/>
+          <a:p>
+            <a:r>
+              <a:rPr sz="2200" b="1">
+                <a:solidFill>
+                  <a:srgbClr val="1B1B2C"/>
+                </a:solidFill>
+                <a:latin typeface="Segoe UI"/>
+              </a:rPr>
+              <a:t>Add-on tip: schedule Cowork prompts</a:t>
+            </a:r>
+          </a:p>
+        </p:txBody>
+      </p:sp>
+      <p:sp>
+        <p:nvSpPr>
+          <p:cNvPr id="4" name="Rectangle 3"/>
+          <p:cNvSpPr/>
+          <p:nvPr/>
+        </p:nvSpPr>
+        <p:spPr>
+          <a:xfrm>
+            <a:off x="502920" y="1115568"/>
+            <a:ext cx="1097280" cy="45720"/>
+          </a:xfrm>
+          <a:prstGeom prst="rect">
+            <a:avLst/>
+          </a:prstGeom>
+          <a:solidFill>
+            <a:srgbClr val="1A6FD6"/>
+          </a:solidFill>
+          <a:ln>
+            <a:noFill/>
+          </a:ln>
+        </p:spPr>
+        <p:style>
+          <a:lnRef idx="1">
+            <a:schemeClr val="accent1"/>
+          </a:lnRef>
+          <a:fillRef idx="3">
+            <a:schemeClr val="accent1"/>
+          </a:fillRef>
+          <a:effectRef idx="2">
+            <a:schemeClr val="accent1"/>
+          </a:effectRef>
+          <a:fontRef idx="minor">
+            <a:schemeClr val="lt1"/>
+          </a:fontRef>
+        </p:style>
+        <p:txBody>
+          <a:bodyPr rtlCol="0" anchor="ctr"/>
+          <a:lstStyle/>
+          <a:p>
+            <a:pPr algn="ctr"/>
+          </a:p>
+        </p:txBody>
+      </p:sp>
+      <p:sp>
+        <p:nvSpPr>
+          <p:cNvPr id="5" name="Rounded Rectangle 4"/>
+          <p:cNvSpPr/>
+          <p:nvPr/>
+        </p:nvSpPr>
+        <p:spPr>
+          <a:xfrm>
+            <a:off x="914400" y="1600200"/>
+            <a:ext cx="7315200" cy="2240280"/>
+          </a:xfrm>
+          <a:prstGeom prst="roundRect">
+            <a:avLst/>
+          </a:prstGeom>
+          <a:solidFill>
+            <a:srgbClr val="FFFFFF"/>
+          </a:solidFill>
+          <a:ln>
+            <a:solidFill>
+              <a:srgbClr val="F6F7FB"/>
+            </a:solidFill>
+          </a:ln>
+        </p:spPr>
+        <p:style>
+          <a:lnRef idx="1">
+            <a:schemeClr val="accent1"/>
+          </a:lnRef>
+          <a:fillRef idx="3">
+            <a:schemeClr val="accent1"/>
+          </a:fillRef>
+          <a:effectRef idx="2">
+            <a:schemeClr val="accent1"/>
+          </a:effectRef>
+          <a:fontRef idx="minor">
+            <a:schemeClr val="lt1"/>
+          </a:fontRef>
+        </p:style>
+        <p:txBody>
+          <a:bodyPr rtlCol="0" anchor="ctr"/>
+          <a:lstStyle/>
+          <a:p>
+            <a:pPr algn="ctr"/>
+          </a:p>
+        </p:txBody>
+      </p:sp>
+      <p:sp>
+        <p:nvSpPr>
+          <p:cNvPr id="6" name="Rectangle 5"/>
+          <p:cNvSpPr/>
+          <p:nvPr/>
+        </p:nvSpPr>
+        <p:spPr>
+          <a:xfrm>
+            <a:off x="914400" y="1600200"/>
+            <a:ext cx="7315200" cy="64008"/>
+          </a:xfrm>
+          <a:prstGeom prst="rect">
+            <a:avLst/>
+          </a:prstGeom>
+          <a:solidFill>
+            <a:srgbClr val="3E8E22"/>
+          </a:solidFill>
+          <a:ln>
+            <a:noFill/>
+          </a:ln>
+        </p:spPr>
+        <p:style>
+          <a:lnRef idx="1">
+            <a:schemeClr val="accent1"/>
+          </a:lnRef>
+          <a:fillRef idx="3">
+            <a:schemeClr val="accent1"/>
+          </a:fillRef>
+          <a:effectRef idx="2">
+            <a:schemeClr val="accent1"/>
+          </a:effectRef>
+          <a:fontRef idx="minor">
+            <a:schemeClr val="lt1"/>
+          </a:fontRef>
+        </p:style>
+        <p:txBody>
+          <a:bodyPr rtlCol="0" anchor="ctr"/>
+          <a:lstStyle/>
+          <a:p>
+            <a:pPr algn="ctr"/>
+          </a:p>
+        </p:txBody>
+      </p:sp>
+      <p:sp>
+        <p:nvSpPr>
+          <p:cNvPr id="7" name="TextBox 6"/>
+          <p:cNvSpPr txBox="1"/>
+          <p:nvPr/>
+        </p:nvSpPr>
+        <p:spPr>
+          <a:xfrm>
+            <a:off x="1234440" y="1901952"/>
+            <a:ext cx="1097280" cy="411480"/>
+          </a:xfrm>
+          <a:prstGeom prst="rect">
+            <a:avLst/>
+          </a:prstGeom>
+          <a:noFill/>
+        </p:spPr>
+        <p:txBody>
+          <a:bodyPr wrap="square" lIns="27432" rIns="27432" tIns="18288" bIns="18288">
+            <a:spAutoFit/>
+          </a:bodyPr>
+          <a:lstStyle/>
+          <a:p>
+            <a:r>
+              <a:rPr sz="2200" b="1">
+                <a:solidFill>
+                  <a:srgbClr val="3E8E22"/>
+                </a:solidFill>
+                <a:latin typeface="Segoe UI"/>
+              </a:rPr>
+              <a:t>Tip</a:t>
+            </a:r>
+          </a:p>
+        </p:txBody>
+      </p:sp>
+      <p:sp>
+        <p:nvSpPr>
+          <p:cNvPr id="8" name="TextBox 7"/>
+          <p:cNvSpPr txBox="1"/>
+          <p:nvPr/>
+        </p:nvSpPr>
+        <p:spPr>
+          <a:xfrm>
+            <a:off x="1234440" y="2514600"/>
+            <a:ext cx="6583680" cy="868680"/>
+          </a:xfrm>
+          <a:prstGeom prst="rect">
+            <a:avLst/>
+          </a:prstGeom>
+          <a:noFill/>
+        </p:spPr>
+        <p:txBody>
+          <a:bodyPr wrap="square" lIns="27432" rIns="27432" tIns="18288" bIns="18288">
+            <a:spAutoFit/>
+          </a:bodyPr>
+          <a:lstStyle/>
+          <a:p>
+            <a:r>
+              <a:rPr sz="1700" b="0">
+                <a:solidFill>
+                  <a:srgbClr val="1B1B2C"/>
+                </a:solidFill>
+                <a:latin typeface="Segoe UI"/>
+              </a:rPr>
+              <a:t>Any of these Cowork tasks can be scheduled to run automatically. In Microsoft 365 Copilot, hover a saved prompt and pick "Schedule this prompt", then choose a daily or weekly cadence (requires a Microsoft 365 Copilot licence).</a:t>
+            </a:r>
+          </a:p>
+        </p:txBody>
+      </p:sp>
+    </p:spTree>
+  </p:cSld>
+  <p:clrMapOvr>
+    <a:masterClrMapping/>
+  </p:clrMapOvr>
+</p:sld>
+</file>
+
+<file path=ppt/slides/slide13.xml><?xml version="1.0" encoding="utf-8"?>
 <p:sld xmlns:a="http://schemas.openxmlformats.org/drawingml/2006/main" xmlns:p="http://schemas.openxmlformats.org/presentationml/2006/main" xmlns:r="http://schemas.openxmlformats.org/officeDocument/2006/relationships">
   <p:cSld>
     <p:bg>

</xml_diff>

<commit_message>
Add source-deck Notes to task modals and slides
Co-authored-by: Copilot <223556219+Copilot@users.noreply.github.com>
</commit_message>
<xml_diff>
--- a/slides/business-lite.pptx
+++ b/slides/business-lite.pptx
@@ -5887,7 +5887,7 @@
         <p:spPr>
           <a:xfrm>
             <a:off x="4892040" y="1874519"/>
-            <a:ext cx="3429000" cy="2148840"/>
+            <a:ext cx="3429000" cy="1783080"/>
           </a:xfrm>
           <a:prstGeom prst="rect">
             <a:avLst/>
@@ -5989,28 +5989,62 @@
         </p:nvSpPr>
         <p:spPr>
           <a:xfrm>
-            <a:off x="4910328" y="4133087"/>
-            <a:ext cx="3337560" cy="310896"/>
-          </a:xfrm>
-          <a:prstGeom prst="rect">
-            <a:avLst/>
-          </a:prstGeom>
-          <a:noFill/>
-        </p:spPr>
-        <p:txBody>
-          <a:bodyPr wrap="square" lIns="27432" rIns="27432" tIns="18288" bIns="18288">
-            <a:spAutoFit/>
-          </a:bodyPr>
-          <a:lstStyle/>
-          <a:p>
-            <a:r>
-              <a:rPr sz="1000" b="0">
+            <a:off x="4910328" y="3968496"/>
+            <a:ext cx="530352" cy="182880"/>
+          </a:xfrm>
+          <a:prstGeom prst="rect">
+            <a:avLst/>
+          </a:prstGeom>
+          <a:noFill/>
+        </p:spPr>
+        <p:txBody>
+          <a:bodyPr wrap="square" lIns="27432" rIns="27432" tIns="18288" bIns="18288">
+            <a:spAutoFit/>
+          </a:bodyPr>
+          <a:lstStyle/>
+          <a:p>
+            <a:r>
+              <a:rPr sz="900" b="1">
+                <a:solidFill>
+                  <a:srgbClr val="1B1B2C"/>
+                </a:solidFill>
+                <a:latin typeface="Segoe UI"/>
+              </a:rPr>
+              <a:t>Note:</a:t>
+            </a:r>
+          </a:p>
+        </p:txBody>
+      </p:sp>
+      <p:sp>
+        <p:nvSpPr>
+          <p:cNvPr id="14" name="TextBox 13"/>
+          <p:cNvSpPr txBox="1"/>
+          <p:nvPr/>
+        </p:nvSpPr>
+        <p:spPr>
+          <a:xfrm>
+            <a:off x="5440680" y="3950208"/>
+            <a:ext cx="2926080" cy="411480"/>
+          </a:xfrm>
+          <a:prstGeom prst="rect">
+            <a:avLst/>
+          </a:prstGeom>
+          <a:noFill/>
+        </p:spPr>
+        <p:txBody>
+          <a:bodyPr wrap="square" lIns="27432" rIns="27432" tIns="18288" bIns="18288">
+            <a:spAutoFit/>
+          </a:bodyPr>
+          <a:lstStyle/>
+          <a:p>
+            <a:r>
+              <a:rPr sz="800" b="0">
                 <a:solidFill>
                   <a:srgbClr val="5A6078"/>
                 </a:solidFill>
                 <a:latin typeface="Segoe UI"/>
               </a:rPr>
-              <a:t>A rebalanced schedule that protects focus time, prioritizes high-impact meetings, and resolves conflicts, without manually negotiating...</a:t>
+              <a:t>You can schedule this to run automatically by starting your prompt with "Create a skill where this occurs every Monday morning."</a:t>
             </a:r>
           </a:p>
         </p:txBody>
@@ -7851,7 +7885,7 @@
         <p:spPr>
           <a:xfrm>
             <a:off x="4892040" y="1874519"/>
-            <a:ext cx="3429000" cy="2148840"/>
+            <a:ext cx="3429000" cy="1783080"/>
           </a:xfrm>
           <a:prstGeom prst="rect">
             <a:avLst/>
@@ -7953,28 +7987,62 @@
         </p:nvSpPr>
         <p:spPr>
           <a:xfrm>
-            <a:off x="4910328" y="4133087"/>
-            <a:ext cx="3337560" cy="310896"/>
-          </a:xfrm>
-          <a:prstGeom prst="rect">
-            <a:avLst/>
-          </a:prstGeom>
-          <a:noFill/>
-        </p:spPr>
-        <p:txBody>
-          <a:bodyPr wrap="square" lIns="27432" rIns="27432" tIns="18288" bIns="18288">
-            <a:spAutoFit/>
-          </a:bodyPr>
-          <a:lstStyle/>
-          <a:p>
-            <a:r>
-              <a:rPr sz="1000" b="0">
+            <a:off x="4910328" y="3968496"/>
+            <a:ext cx="530352" cy="182880"/>
+          </a:xfrm>
+          <a:prstGeom prst="rect">
+            <a:avLst/>
+          </a:prstGeom>
+          <a:noFill/>
+        </p:spPr>
+        <p:txBody>
+          <a:bodyPr wrap="square" lIns="27432" rIns="27432" tIns="18288" bIns="18288">
+            <a:spAutoFit/>
+          </a:bodyPr>
+          <a:lstStyle/>
+          <a:p>
+            <a:r>
+              <a:rPr sz="900" b="1">
+                <a:solidFill>
+                  <a:srgbClr val="1B1B2C"/>
+                </a:solidFill>
+                <a:latin typeface="Segoe UI"/>
+              </a:rPr>
+              <a:t>Note:</a:t>
+            </a:r>
+          </a:p>
+        </p:txBody>
+      </p:sp>
+      <p:sp>
+        <p:nvSpPr>
+          <p:cNvPr id="14" name="TextBox 13"/>
+          <p:cNvSpPr txBox="1"/>
+          <p:nvPr/>
+        </p:nvSpPr>
+        <p:spPr>
+          <a:xfrm>
+            <a:off x="5440680" y="3950208"/>
+            <a:ext cx="2926080" cy="411480"/>
+          </a:xfrm>
+          <a:prstGeom prst="rect">
+            <a:avLst/>
+          </a:prstGeom>
+          <a:noFill/>
+        </p:spPr>
+        <p:txBody>
+          <a:bodyPr wrap="square" lIns="27432" rIns="27432" tIns="18288" bIns="18288">
+            <a:spAutoFit/>
+          </a:bodyPr>
+          <a:lstStyle/>
+          <a:p>
+            <a:r>
+              <a:rPr sz="800" b="0">
                 <a:solidFill>
                   <a:srgbClr val="5A6078"/>
                 </a:solidFill>
                 <a:latin typeface="Segoe UI"/>
               </a:rPr>
-              <a:t>A curated weekly brief that surfaces meaningful trends across the publications you follow, without the time spent reading them.</a:t>
+              <a:t>This task features a scheduled prompt, which tells Cowork you want it to run automatically on a recurring basis. To create a scheduled prompt, simply describe what...</a:t>
             </a:r>
           </a:p>
         </p:txBody>

</xml_diff>